<commit_message>
fix(presentation): correct errors 1-5 in PPTX slides and mark as fixed in DECK_REVIEW.md
</commit_message>
<xml_diff>
--- a/presentation/EnSIUMble_ML_Project_2025.pptx
+++ b/presentation/EnSIUMble_ML_Project_2025.pptx
@@ -7713,7 +7713,7 @@
                 <a:ea typeface="Courier New" pitchFamily="34" charset="-122"/>
                 <a:cs typeface="Courier New" pitchFamily="34" charset="-120"/>
               </a:rPr>
-              <a:t>[256, 256, 256] · adamw · gelu · 66 epochs</a:t>
+              <a:t>[256, 256, 256] · adamw · gelu · 68 epochs</a:t>
             </a:r>
             <a:endParaRPr lang="en-US" sz="2100" dirty="0"/>
           </a:p>
@@ -9478,7 +9478,7 @@
                 <a:ea typeface="Arial" pitchFamily="34" charset="-122"/>
                 <a:cs typeface="Arial" pitchFamily="34" charset="-120"/>
               </a:rPr>
-              <a:t>K-NN's zero training error is memorisation, not skill — which is exactly why it is useful in the stack: its error pattern is uncorrelated with the MLP's. The meta-learner beats every member on both validation and test, and validation-to-test drift is 0.0426, so the selection was not overfitted to the folds.</a:t>
+              <a:t>K-NN's zero training error is memorisation, not skill — which is exactly why it is useful in the stack: its error pattern is uncorrelated with the MLP's. The meta-learner beats every member on out-of-fold validation and matches the best member on test, with the lowest validation-to-test drift of any model in the study (0.0426) — it buys stability across partitions rather than a lower headline number.</a:t>
             </a:r>
             <a:endParaRPr lang="en-US" sz="2250" dirty="0"/>
           </a:p>
@@ -11530,7 +11530,7 @@
                 <a:ea typeface="Arial" pitchFamily="34" charset="-122"/>
                 <a:cs typeface="Arial" pitchFamily="34" charset="-120"/>
               </a:rPr>
-              <a:t>The final model costs three pipelines plus a meta-fit for a 17.5% improvement over its best member. Worth it when scored on generalisation; for a latency-bound deployment, K-NN alone at 14.1284 is the honest first choice.</a:t>
+              <a:t>The final model costs three pipelines plus a meta-fit for a 45.3% improvement over OLS baseline. Worth it when scored on generalisation; for a latency-bound deployment, K-NN alone at 14.1284 is the honest first choice.</a:t>
             </a:r>
             <a:endParaRPr lang="en-US" sz="2325" dirty="0"/>
           </a:p>
@@ -11872,7 +11872,7 @@
                 <a:ea typeface="Arial" pitchFamily="34" charset="-122"/>
                 <a:cs typeface="Arial" pitchFamily="34" charset="-120"/>
               </a:rPr>
-              <a:t>Error is Mean Euclidean Error over a two-dimensional target:</a:t>
+              <a:t>Error is Mean Euclidean Error over a four-dimensional target:</a:t>
             </a:r>
             <a:endParaRPr lang="en-US" sz="2400" dirty="0"/>
           </a:p>
@@ -15793,7 +15793,7 @@
                 <a:ea typeface="Courier New" pitchFamily="34" charset="-122"/>
                 <a:cs typeface="Courier New" pitchFamily="34" charset="-120"/>
               </a:rPr>
-              <a:t>L2 · λ = 0.001</a:t>
+              <a:t>L2 · λ = 10.0</a:t>
             </a:r>
             <a:endParaRPr lang="en-US" sz="1800" dirty="0"/>
           </a:p>
@@ -16536,7 +16536,7 @@
                 <a:ea typeface="Arial" pitchFamily="34" charset="-122"/>
                 <a:cs typeface="Arial" pitchFamily="34" charset="-120"/>
               </a:rPr>
-              <a:t>A collinear 12-feature input space, a two-dimensional target, and a baseline to beat.</a:t>
+              <a:t>A collinear 12-feature input space, a four-dimensional target, and a baseline to beat.</a:t>
             </a:r>
             <a:endParaRPr lang="en-US" sz="2700" dirty="0"/>
           </a:p>

</xml_diff>